<commit_message>
Add description for last mistake
</commit_message>
<xml_diff>
--- a/Task7/Лр7_KodusAI Небоваренков Зверь.pptx
+++ b/Task7/Лр7_KodusAI Небоваренков Зверь.pptx
@@ -217,7 +217,7 @@
           <a:p>
             <a:fld id="{B1C684E2-121A-4D6B-9071-5C929EF90B75}" type="datetimeFigureOut">
               <a:rPr lang="ru-RU" smtClean="0"/>
-              <a:t>09.04.2026</a:t>
+              <a:t>16.04.2026</a:t>
             </a:fld>
             <a:endParaRPr lang="ru-RU"/>
           </a:p>
@@ -640,6 +640,90 @@
           <a:p>
             <a:fld id="{788D1AEF-DD74-4B85-93D8-3C2C0F18F670}" type="slidenum">
               <a:rPr lang="ru-RU" smtClean="0"/>
+              <a:t>17</a:t>
+            </a:fld>
+            <a:endParaRPr lang="ru-RU"/>
+          </a:p>
+        </p:txBody>
+      </p:sp>
+    </p:spTree>
+    <p:extLst>
+      <p:ext uri="{BB962C8B-B14F-4D97-AF65-F5344CB8AC3E}">
+        <p14:creationId xmlns:p14="http://schemas.microsoft.com/office/powerpoint/2010/main" val="3344848779"/>
+      </p:ext>
+    </p:extLst>
+  </p:cSld>
+  <p:clrMapOvr>
+    <a:masterClrMapping/>
+  </p:clrMapOvr>
+</p:notes>
+</file>
+
+<file path=ppt/notesSlides/notesSlide3.xml><?xml version="1.0" encoding="utf-8"?>
+<p:notes xmlns:a="http://schemas.openxmlformats.org/drawingml/2006/main" xmlns:r="http://schemas.openxmlformats.org/officeDocument/2006/relationships" xmlns:p="http://schemas.openxmlformats.org/presentationml/2006/main">
+  <p:cSld>
+    <p:spTree>
+      <p:nvGrpSpPr>
+        <p:cNvPr id="1" name=""/>
+        <p:cNvGrpSpPr/>
+        <p:nvPr/>
+      </p:nvGrpSpPr>
+      <p:grpSpPr>
+        <a:xfrm>
+          <a:off x="0" y="0"/>
+          <a:ext cx="0" cy="0"/>
+          <a:chOff x="0" y="0"/>
+          <a:chExt cx="0" cy="0"/>
+        </a:xfrm>
+      </p:grpSpPr>
+      <p:sp>
+        <p:nvSpPr>
+          <p:cNvPr id="2" name="Образ слайда 1"/>
+          <p:cNvSpPr>
+            <a:spLocks noGrp="1" noRot="1" noChangeAspect="1"/>
+          </p:cNvSpPr>
+          <p:nvPr>
+            <p:ph type="sldImg"/>
+          </p:nvPr>
+        </p:nvSpPr>
+        <p:spPr/>
+      </p:sp>
+      <p:sp>
+        <p:nvSpPr>
+          <p:cNvPr id="3" name="Заметки 2"/>
+          <p:cNvSpPr>
+            <a:spLocks noGrp="1"/>
+          </p:cNvSpPr>
+          <p:nvPr>
+            <p:ph type="body" idx="1"/>
+          </p:nvPr>
+        </p:nvSpPr>
+        <p:spPr/>
+        <p:txBody>
+          <a:bodyPr/>
+          <a:lstStyle/>
+          <a:p>
+            <a:endParaRPr lang="ru-RU" dirty="0"/>
+          </a:p>
+        </p:txBody>
+      </p:sp>
+      <p:sp>
+        <p:nvSpPr>
+          <p:cNvPr id="4" name="Номер слайда 3"/>
+          <p:cNvSpPr>
+            <a:spLocks noGrp="1"/>
+          </p:cNvSpPr>
+          <p:nvPr>
+            <p:ph type="sldNum" sz="quarter" idx="5"/>
+          </p:nvPr>
+        </p:nvSpPr>
+        <p:spPr/>
+        <p:txBody>
+          <a:bodyPr/>
+          <a:lstStyle/>
+          <a:p>
+            <a:fld id="{788D1AEF-DD74-4B85-93D8-3C2C0F18F670}" type="slidenum">
+              <a:rPr lang="ru-RU" smtClean="0"/>
               <a:t>18</a:t>
             </a:fld>
             <a:endParaRPr lang="ru-RU"/>
@@ -788,7 +872,7 @@
           <a:p>
             <a:fld id="{B9D6247F-6AF4-4318-A27B-4F8FC20FB9AC}" type="datetime1">
               <a:rPr lang="ru-RU" smtClean="0"/>
-              <a:t>09.04.2026</a:t>
+              <a:t>16.04.2026</a:t>
             </a:fld>
             <a:endParaRPr lang="ru-RU"/>
           </a:p>
@@ -956,7 +1040,7 @@
           <a:p>
             <a:fld id="{AF31D271-C6DA-48C3-BCC1-D133AD7203D4}" type="datetime1">
               <a:rPr lang="ru-RU" smtClean="0"/>
-              <a:t>09.04.2026</a:t>
+              <a:t>16.04.2026</a:t>
             </a:fld>
             <a:endParaRPr lang="ru-RU"/>
           </a:p>
@@ -1134,7 +1218,7 @@
           <a:p>
             <a:fld id="{A960878F-82B3-4277-A62B-1A7C958B7AFD}" type="datetime1">
               <a:rPr lang="ru-RU" smtClean="0"/>
-              <a:t>09.04.2026</a:t>
+              <a:t>16.04.2026</a:t>
             </a:fld>
             <a:endParaRPr lang="ru-RU"/>
           </a:p>
@@ -1302,7 +1386,7 @@
           <a:p>
             <a:fld id="{AF145611-9BEC-4F6E-A7A2-016B98ED9A5B}" type="datetime1">
               <a:rPr lang="ru-RU" smtClean="0"/>
-              <a:t>09.04.2026</a:t>
+              <a:t>16.04.2026</a:t>
             </a:fld>
             <a:endParaRPr lang="ru-RU"/>
           </a:p>
@@ -1547,7 +1631,7 @@
           <a:p>
             <a:fld id="{A2FEA4DD-3B4D-4EAE-9A17-ACA5EF5AE5AE}" type="datetime1">
               <a:rPr lang="ru-RU" smtClean="0"/>
-              <a:t>09.04.2026</a:t>
+              <a:t>16.04.2026</a:t>
             </a:fld>
             <a:endParaRPr lang="ru-RU"/>
           </a:p>
@@ -1776,7 +1860,7 @@
           <a:p>
             <a:fld id="{9264AF9E-18B6-4C53-A9EB-01F4D00D3082}" type="datetime1">
               <a:rPr lang="ru-RU" smtClean="0"/>
-              <a:t>09.04.2026</a:t>
+              <a:t>16.04.2026</a:t>
             </a:fld>
             <a:endParaRPr lang="ru-RU"/>
           </a:p>
@@ -2140,7 +2224,7 @@
           <a:p>
             <a:fld id="{8F55B0F0-0CD9-4813-B860-AB929393F0BC}" type="datetime1">
               <a:rPr lang="ru-RU" smtClean="0"/>
-              <a:t>09.04.2026</a:t>
+              <a:t>16.04.2026</a:t>
             </a:fld>
             <a:endParaRPr lang="ru-RU"/>
           </a:p>
@@ -2257,7 +2341,7 @@
           <a:p>
             <a:fld id="{8E5CD37D-B4E5-478E-B1C6-9811DB3A2BC3}" type="datetime1">
               <a:rPr lang="ru-RU" smtClean="0"/>
-              <a:t>09.04.2026</a:t>
+              <a:t>16.04.2026</a:t>
             </a:fld>
             <a:endParaRPr lang="ru-RU"/>
           </a:p>
@@ -2352,7 +2436,7 @@
           <a:p>
             <a:fld id="{B0455336-877F-4B9E-ABA0-711209675E90}" type="datetime1">
               <a:rPr lang="ru-RU" smtClean="0"/>
-              <a:t>09.04.2026</a:t>
+              <a:t>16.04.2026</a:t>
             </a:fld>
             <a:endParaRPr lang="ru-RU"/>
           </a:p>
@@ -2627,7 +2711,7 @@
           <a:p>
             <a:fld id="{4CD7FBEC-B4E5-42F6-9401-C269C822CB37}" type="datetime1">
               <a:rPr lang="ru-RU" smtClean="0"/>
-              <a:t>09.04.2026</a:t>
+              <a:t>16.04.2026</a:t>
             </a:fld>
             <a:endParaRPr lang="ru-RU"/>
           </a:p>
@@ -2879,7 +2963,7 @@
           <a:p>
             <a:fld id="{164E4ED0-DB39-4DEB-BDB8-65B049CA9302}" type="datetime1">
               <a:rPr lang="ru-RU" smtClean="0"/>
-              <a:t>09.04.2026</a:t>
+              <a:t>16.04.2026</a:t>
             </a:fld>
             <a:endParaRPr lang="ru-RU"/>
           </a:p>
@@ -3090,7 +3174,7 @@
           <a:p>
             <a:fld id="{7C87ADCC-E2E8-4FE7-9F77-8D106CD66237}" type="datetime1">
               <a:rPr lang="ru-RU" smtClean="0"/>
-              <a:t>09.04.2026</a:t>
+              <a:t>16.04.2026</a:t>
             </a:fld>
             <a:endParaRPr lang="ru-RU"/>
           </a:p>
@@ -5570,7 +5654,7 @@
           <p:nvPr/>
         </p:nvPicPr>
         <p:blipFill>
-          <a:blip r:embed="rId2"/>
+          <a:blip r:embed="rId3"/>
           <a:stretch>
             <a:fillRect/>
           </a:stretch>
@@ -5600,14 +5684,14 @@
           <p:nvPr/>
         </p:nvPicPr>
         <p:blipFill>
-          <a:blip r:embed="rId3"/>
+          <a:blip r:embed="rId4"/>
           <a:stretch>
             <a:fillRect/>
           </a:stretch>
         </p:blipFill>
         <p:spPr>
           <a:xfrm>
-            <a:off x="7464391" y="1562799"/>
+            <a:off x="8114312" y="1524298"/>
             <a:ext cx="2734376" cy="634375"/>
           </a:xfrm>
           <a:prstGeom prst="rect">
@@ -5630,15 +5714,15 @@
           <p:nvPr/>
         </p:nvPicPr>
         <p:blipFill>
-          <a:blip r:embed="rId4"/>
+          <a:blip r:embed="rId5"/>
           <a:stretch>
             <a:fillRect/>
           </a:stretch>
         </p:blipFill>
         <p:spPr>
           <a:xfrm>
-            <a:off x="2877952" y="2763293"/>
-            <a:ext cx="2147777" cy="1955140"/>
+            <a:off x="2803318" y="2695353"/>
+            <a:ext cx="2222411" cy="2023080"/>
           </a:xfrm>
           <a:prstGeom prst="rect">
             <a:avLst/>
@@ -5660,7 +5744,7 @@
           <p:nvPr/>
         </p:nvPicPr>
         <p:blipFill>
-          <a:blip r:embed="rId5"/>
+          <a:blip r:embed="rId6"/>
           <a:stretch>
             <a:fillRect/>
           </a:stretch>
@@ -5690,7 +5774,7 @@
           <p:nvPr/>
         </p:nvPicPr>
         <p:blipFill>
-          <a:blip r:embed="rId6"/>
+          <a:blip r:embed="rId7"/>
           <a:stretch>
             <a:fillRect/>
           </a:stretch>
@@ -5720,7 +5804,7 @@
           <p:nvPr/>
         </p:nvPicPr>
         <p:blipFill>
-          <a:blip r:embed="rId7"/>
+          <a:blip r:embed="rId8"/>
           <a:stretch>
             <a:fillRect/>
           </a:stretch>
@@ -5846,7 +5930,7 @@
           <p:nvPr>
             <p:extLst>
               <p:ext uri="{D42A27DB-BD31-4B8C-83A1-F6EECF244321}">
-                <p14:modId xmlns:p14="http://schemas.microsoft.com/office/powerpoint/2010/main" val="2440214309"/>
+                <p14:modId xmlns:p14="http://schemas.microsoft.com/office/powerpoint/2010/main" val="1568070612"/>
               </p:ext>
             </p:extLst>
           </p:nvPr>
@@ -6605,8 +6689,91 @@
         </p:blipFill>
         <p:spPr>
           <a:xfrm>
-            <a:off x="2413591" y="5809947"/>
+            <a:off x="7863416" y="5735519"/>
             <a:ext cx="3295520" cy="911527"/>
+          </a:xfrm>
+          <a:prstGeom prst="rect">
+            <a:avLst/>
+          </a:prstGeom>
+        </p:spPr>
+      </p:pic>
+      <p:sp>
+        <p:nvSpPr>
+          <p:cNvPr id="5" name="TextBox 4">
+            <a:extLst>
+              <a:ext uri="{FF2B5EF4-FFF2-40B4-BE49-F238E27FC236}">
+                <a16:creationId xmlns:a16="http://schemas.microsoft.com/office/drawing/2014/main" id="{7F54B037-102C-26A4-A16E-5735C34546C1}"/>
+              </a:ext>
+            </a:extLst>
+          </p:cNvPr>
+          <p:cNvSpPr txBox="1"/>
+          <p:nvPr/>
+        </p:nvSpPr>
+        <p:spPr>
+          <a:xfrm>
+            <a:off x="7863416" y="5399479"/>
+            <a:ext cx="3418368" cy="261610"/>
+          </a:xfrm>
+          <a:prstGeom prst="rect">
+            <a:avLst/>
+          </a:prstGeom>
+          <a:noFill/>
+        </p:spPr>
+        <p:txBody>
+          <a:bodyPr wrap="square" rtlCol="0">
+            <a:spAutoFit/>
+          </a:bodyPr>
+          <a:lstStyle/>
+          <a:p>
+            <a:pPr algn="ctr"/>
+            <a:r>
+              <a:rPr lang="ru-RU" sz="1100" dirty="0">
+                <a:solidFill>
+                  <a:schemeClr val="dk1"/>
+                </a:solidFill>
+              </a:rPr>
+              <a:t>Убран </a:t>
+            </a:r>
+            <a:r>
+              <a:rPr lang="en-US" sz="1100" dirty="0">
+                <a:solidFill>
+                  <a:schemeClr val="dk1"/>
+                </a:solidFill>
+              </a:rPr>
+              <a:t>const</a:t>
+            </a:r>
+            <a:endParaRPr lang="ru-RU" sz="1100" dirty="0">
+              <a:solidFill>
+                <a:schemeClr val="dk1"/>
+              </a:solidFill>
+            </a:endParaRPr>
+          </a:p>
+        </p:txBody>
+      </p:sp>
+      <p:pic>
+        <p:nvPicPr>
+          <p:cNvPr id="8" name="Рисунок 7">
+            <a:extLst>
+              <a:ext uri="{FF2B5EF4-FFF2-40B4-BE49-F238E27FC236}">
+                <a16:creationId xmlns:a16="http://schemas.microsoft.com/office/drawing/2014/main" id="{7C8ED7C8-098D-3E99-BF48-9A8C019C1237}"/>
+              </a:ext>
+            </a:extLst>
+          </p:cNvPr>
+          <p:cNvPicPr>
+            <a:picLocks noChangeAspect="1"/>
+          </p:cNvPicPr>
+          <p:nvPr/>
+        </p:nvPicPr>
+        <p:blipFill>
+          <a:blip r:embed="rId10"/>
+          <a:stretch>
+            <a:fillRect/>
+          </a:stretch>
+        </p:blipFill>
+        <p:spPr>
+          <a:xfrm>
+            <a:off x="1592232" y="6032455"/>
+            <a:ext cx="4791744" cy="323895"/>
           </a:xfrm>
           <a:prstGeom prst="rect">
             <a:avLst/>

</xml_diff>